<commit_message>
M16: regenerate hollowell-ip under the wave's knobs (baseline + mail demonstrator)
Wholesale regen through the live airlock (claude-opus-4-8[1m], xhigh).
Baseline realism (business_calendar: weekend meetings 0/0, book_is_sample,
style_specs: 10 specs, voice_diversify) plus the fleet's first real mail
threads: engagement mail runs as In-Reply-To chains (eml raised 3->18 above
the 5 engagements), 4 mundane internal emails with exempt_author_mentions,
1 distribution list. Client-facing replies authored in a client register;
mundane authors no longer self-name (criterion 7 proof bed, board to
confirm). Validates clean (29 rules, EML/DL run, 0 errors); self-scores
100%; byte-pin re-derives; org-tier green.
</commit_message>
<xml_diff>
--- a/companies/hollowell-ip/Engagements/Odonnell Inc/2019.07.05 - Briefing Deck - Odonnell Inc.pptx
+++ b/companies/hollowell-ip/Engagements/Odonnell Inc/2019.07.05 - Briefing Deck - Odonnell Inc.pptx
@@ -3114,7 +3114,7 @@
                   <a:srgbClr val="1E4D2B"/>
                 </a:solidFill>
               </a:rPr>
-              <a:t>Patent Portfolio Review: Odonnell Inc</a:t>
+              <a:t>Patent Portfolio Review for Odonnell Inc</a:t>
             </a:r>
           </a:p>
         </p:txBody>
@@ -3141,31 +3141,25 @@
           <a:p>
             <a:pPr lvl="1"/>
             <a:r>
-              <a:t>Prepared for Gary Smith, General Manager</a:t>
+              <a:t>Progress briefing prepared for Gary Smith, General Manager</a:t>
             </a:r>
           </a:p>
           <a:p>
             <a:pPr lvl="1"/>
             <a:r>
+              <a:t>Engagement commenced May 13, 2019</a:t>
+            </a:r>
+          </a:p>
+          <a:p>
+            <a:pPr lvl="1"/>
+            <a:r>
+              <a:t>Review led by Heather Munoz, Partner</a:t>
+            </a:r>
+          </a:p>
+          <a:p>
+            <a:pPr lvl="1"/>
+            <a:r>
               <a:t>Prepared by Kelly Snyder, Patent Agent</a:t>
-            </a:r>
-          </a:p>
-          <a:p>
-            <a:pPr lvl="1"/>
-            <a:r>
-              <a:t>Reviewed by Heather Munoz, Partner</a:t>
-            </a:r>
-          </a:p>
-          <a:p>
-            <a:pPr lvl="1"/>
-            <a:r>
-              <a:t>Engagement commenced May 13, 2019; approximately seven months end to end</a:t>
-            </a:r>
-          </a:p>
-          <a:p>
-            <a:pPr lvl="1"/>
-            <a:r>
-              <a:t>Privileged and confidential. Prepared for the board of Odonnell Inc and not for circulation</a:t>
             </a:r>
           </a:p>
         </p:txBody>
@@ -3209,7 +3203,7 @@
                   <a:srgbClr val="1E4D2B"/>
                 </a:solidFill>
               </a:rPr>
-              <a:t>What We Were Asked To Do</a:t>
+              <a:t>What We Are Reviewing</a:t>
             </a:r>
           </a:p>
         </p:txBody>
@@ -3231,31 +3225,31 @@
           <a:p>
             <a:pPr lvl="1"/>
             <a:r>
-              <a:t>Establish, family by family, what is actually on file and who owns it</a:t>
+              <a:t>Every patent and pending application in the portfolio, taken one family at a time</a:t>
             </a:r>
           </a:p>
           <a:p>
             <a:pPr lvl="1"/>
             <a:r>
-              <a:t>Compare issued and pending claims against the products you designate</a:t>
+              <a:t>Docketed dates reconciled against the office record for each family</a:t>
             </a:r>
           </a:p>
           <a:p>
             <a:pPr lvl="1"/>
             <a:r>
-              <a:t>Identify where continuation and divisional practice remains open, and when it closes</a:t>
+              <a:t>Prosecution history and the current claim scope, family by family</a:t>
             </a:r>
           </a:p>
           <a:p>
             <a:pPr lvl="1"/>
             <a:r>
-              <a:t>Verify every deadline in the portfolio against our own docket</a:t>
+              <a:t>Any filing, response, or decision that is coming due</a:t>
             </a:r>
           </a:p>
           <a:p>
             <a:pPr lvl="1"/>
             <a:r>
-              <a:t>Deliver written findings organized by family, each carrying the record behind it</a:t>
+              <a:t>What sits outside the review: no new filings and no office-action responses under this engagement</a:t>
             </a:r>
           </a:p>
         </p:txBody>
@@ -3299,7 +3293,7 @@
                   <a:srgbClr val="1E4D2B"/>
                 </a:solidFill>
               </a:rPr>
-              <a:t>Where the Work Stands</a:t>
+              <a:t>How the Review Runs</a:t>
             </a:r>
           </a:p>
         </p:txBody>
@@ -3321,31 +3315,31 @@
           <a:p>
             <a:pPr lvl="1"/>
             <a:r>
-              <a:t>Portfolio inventory complete; every family identified and opened on our docket</a:t>
+              <a:t>Families are reviewed in docket order, the closest deadlines first</a:t>
             </a:r>
           </a:p>
           <a:p>
             <a:pPr lvl="1"/>
             <a:r>
-              <a:t>File histories reconstructed for roughly half the families; the remainder are ordered</a:t>
+              <a:t>Kelly Snyder keeps the portfolio docket current and reconciles every date against the office record</a:t>
             </a:r>
           </a:p>
           <a:p>
             <a:pPr lvl="1"/>
             <a:r>
-              <a:t>Chain of title confirmed on the families reviewed to date, with one recording gap listed and being chased</a:t>
+              <a:t>Amanda Schwartz reconciles each file history and flags gaps for retrieval</a:t>
             </a:r>
           </a:p>
           <a:p>
             <a:pPr lvl="1"/>
             <a:r>
-              <a:t>Claim mapping under way on the families where the record is complete</a:t>
+              <a:t>Heather Munoz reviews claim scope and prosecution posture and owns the conclusions</a:t>
             </a:r>
           </a:p>
           <a:p>
             <a:pPr lvl="1"/>
             <a:r>
-              <a:t>Early phase: what follows is inventory and observation, not advice</a:t>
+              <a:t>One master date list governs the work, reconciled weekly</a:t>
             </a:r>
           </a:p>
         </p:txBody>
@@ -3389,7 +3383,7 @@
                   <a:srgbClr val="1E4D2B"/>
                 </a:solidFill>
               </a:rPr>
-              <a:t>Observations To Date</a:t>
+              <a:t>Where the Work Stands</a:t>
             </a:r>
           </a:p>
         </p:txBody>
@@ -3411,25 +3405,31 @@
           <a:p>
             <a:pPr lvl="1"/>
             <a:r>
-              <a:t>The portfolio reads as families, not as a stack of independent files, which is a better starting position than most reviews find</a:t>
+              <a:t>The portfolio is pulled and fully docketed</a:t>
             </a:r>
           </a:p>
           <a:p>
             <a:pPr lvl="1"/>
             <a:r>
-              <a:t>Continuation practice appears to remain open in more than one family; whether it is worth exercising is a question for the findings, not for this deck</a:t>
+              <a:t>File-history reconciliation is under way, the larger families first</a:t>
             </a:r>
           </a:p>
           <a:p>
             <a:pPr lvl="1"/>
             <a:r>
-              <a:t>One family's claims and the product designations do not line up as cleanly as the file suggests; Amanda Schwartz is working it</a:t>
+              <a:t>The first substantive review passes are beginning</a:t>
             </a:r>
           </a:p>
           <a:p>
             <a:pPr lvl="1"/>
             <a:r>
-              <a:t>Our docket and the schedule kept before this engagement disagree on a small number of entries; we are working from the earlier date in each case until the file resolves it</a:t>
+              <a:t>No docket date is currently at risk</a:t>
+            </a:r>
+          </a:p>
+          <a:p>
+            <a:pPr lvl="1"/>
+            <a:r>
+              <a:t>Observations only at this stage; no conclusions are offered yet</a:t>
             </a:r>
           </a:p>
         </p:txBody>
@@ -3473,7 +3473,7 @@
                   <a:srgbClr val="1E4D2B"/>
                 </a:solidFill>
               </a:rPr>
-              <a:t>What We Need From You</a:t>
+              <a:t>What the Review Will Deliver</a:t>
             </a:r>
           </a:p>
         </p:txBody>
@@ -3495,25 +3495,31 @@
           <a:p>
             <a:pPr lvl="1"/>
             <a:r>
-              <a:t>Product designations confirmed in writing, family by family</a:t>
+              <a:t>A single written review, organized family by family</a:t>
             </a:r>
           </a:p>
           <a:p>
             <a:pPr lvl="1"/>
             <a:r>
-              <a:t>Your copies of the assignment records for the earliest family</a:t>
+              <a:t>The docket confirmed against the office record, with any correction noted and sourced</a:t>
             </a:r>
           </a:p>
           <a:p>
             <a:pPr lvl="1"/>
             <a:r>
-              <a:t>A named person on your side for questions of commercial intent, where the answer is a business judgment and not a legal one</a:t>
+              <a:t>Claim scope and prosecution posture summarized for each family</a:t>
             </a:r>
           </a:p>
           <a:p>
             <a:pPr lvl="1"/>
             <a:r>
-              <a:t>Notice of anything filed, licensed, or asserted that we would not find in the official file</a:t>
+              <a:t>Deadlines identified early enough to be acted on deliberately</a:t>
+            </a:r>
+          </a:p>
+          <a:p>
+            <a:pPr lvl="1"/>
+            <a:r>
+              <a:t>The decisions we believe Odonnell Inc should weigh</a:t>
             </a:r>
           </a:p>
         </p:txBody>
@@ -3557,7 +3563,7 @@
                   <a:srgbClr val="1E4D2B"/>
                 </a:solidFill>
               </a:rPr>
-              <a:t>Next Steps</a:t>
+              <a:t>What Comes Next</a:t>
             </a:r>
           </a:p>
         </p:txBody>
@@ -3579,31 +3585,31 @@
           <a:p>
             <a:pPr lvl="1"/>
             <a:r>
-              <a:t>Complete the remaining file histories and close the recording gap</a:t>
+              <a:t>Complete the file-history reconciliation across the portfolio</a:t>
             </a:r>
           </a:p>
           <a:p>
             <a:pPr lvl="1"/>
             <a:r>
-              <a:t>Finish claim mapping across all families; Amanda Schwartz owns the comparison</a:t>
+              <a:t>Work through the substantive review in docket order</a:t>
             </a:r>
           </a:p>
           <a:p>
             <a:pPr lvl="1"/>
             <a:r>
-              <a:t>Heather Munoz to draft the family-level positions once the mapping is complete</a:t>
+              <a:t>Retrieve any documents missing from the histories</a:t>
             </a:r>
           </a:p>
           <a:p>
             <a:pPr lvl="1"/>
             <a:r>
-              <a:t>Reconcile every disputed docket entry against the official record and report the result in writing</a:t>
+              <a:t>Report any date at risk to Gary Smith the day it is identified</a:t>
             </a:r>
           </a:p>
           <a:p>
             <a:pPr lvl="1"/>
             <a:r>
-              <a:t>Periodic written reports continue against the matter docket; Kelly Snyder is your point of contact between them</a:t>
+              <a:t>Hold the next briefing once the first families are through review</a:t>
             </a:r>
           </a:p>
         </p:txBody>

</xml_diff>